<commit_message>
Fill presenter details into RESER 2026 decks
Add Shin Suzuki (Fukuyama University) and contact e-mail to the title and
closing slides of the generated deck, and to the uploaded alternative deck.

Co-Authored-By: Claude Fable 5.1 <noreply@anthropic.com>
Claude-Session: https://claude.ai/code/session_017iAjFETDQM8J1dXFzTHKRu
</commit_message>
<xml_diff>
--- a/presentations/RESER2026/RESER2026_slides.pptx
+++ b/presentations/RESER2026/RESER2026_slides.pptx
@@ -5446,7 +5446,7 @@
                 <a:latin typeface="Calibri"/>
                 <a:cs typeface="Calibri"/>
               </a:rPr>
-              <a:t>[Presenter name]</a:t>
+              <a:t>Shin Suzuki</a:t>
             </a:r>
             <a:r>
               <a:rPr lang="en-US" sz="1500" b="0" i="0" dirty="0">
@@ -5456,7 +5456,7 @@
                 <a:latin typeface="Calibri"/>
                 <a:cs typeface="Calibri"/>
               </a:rPr>
-              <a:t xml:space="preserve">  ·  [Affiliation]</a:t>
+              <a:t xml:space="preserve">  ·  Senior Lecturer, Faculty of Economics, Fukuyama University</a:t>
             </a:r>
           </a:p>
           <a:p>
@@ -5477,7 +5477,7 @@
                 <a:latin typeface="Calibri"/>
                 <a:cs typeface="Calibri"/>
               </a:rPr>
-              <a:t>[Co-author names and affiliations]</a:t>
+              <a:t>s.suzuki@fukuyama-u.ac.jp</a:t>
             </a:r>
           </a:p>
         </p:txBody>
@@ -12097,7 +12097,7 @@
                 <a:latin typeface="Calibri"/>
                 <a:cs typeface="Calibri"/>
               </a:rPr>
-              <a:t>[Presenter name]</a:t>
+              <a:t>Shin Suzuki</a:t>
             </a:r>
           </a:p>
           <a:p>
@@ -12118,7 +12118,7 @@
                 <a:latin typeface="Calibri"/>
                 <a:cs typeface="Calibri"/>
               </a:rPr>
-              <a:t>[Affiliation]</a:t>
+              <a:t>Senior Lecturer, Faculty of Economics, Fukuyama University</a:t>
             </a:r>
           </a:p>
           <a:p>
@@ -12139,7 +12139,7 @@
                 <a:latin typeface="Calibri"/>
                 <a:cs typeface="Calibri"/>
               </a:rPr>
-              <a:t>[e-mail address]</a:t>
+              <a:t>s.suzuki@fukuyama-u.ac.jp</a:t>
             </a:r>
           </a:p>
           <a:p>

</xml_diff>